<commit_message>
Addedd topic 2 llm
</commit_message>
<xml_diff>
--- a/topic-2/talk-1/ReactJS_01.pptx
+++ b/topic-2/talk-1/ReactJS_01.pptx
@@ -14850,13 +14850,13 @@
           <p:nvPr/>
         </p:nvPicPr>
         <p:blipFill>
-          <a:blip r:embed="rId3">
+          <a:blip>
             <a:extLst>
               <a:ext uri="{28A0092B-C50C-407E-A947-70E740481C1C}">
                 <a14:useLocalDpi xmlns:a14="http://schemas.microsoft.com/office/drawing/2010/main" val="0"/>
               </a:ext>
               <a:ext uri="{96DAC541-7B7A-43D3-8B79-37D633B846F1}">
-                <asvg:svgBlip xmlns:asvg="http://schemas.microsoft.com/office/drawing/2016/SVG/main" r:embed="rId4"/>
+                <asvg:svgBlip xmlns:asvg="http://schemas.microsoft.com/office/drawing/2016/SVG/main" r:embed="rId3"/>
               </a:ext>
             </a:extLst>
           </a:blip>
@@ -15824,13 +15824,13 @@
           <p:nvPr/>
         </p:nvPicPr>
         <p:blipFill>
-          <a:blip r:embed="rId3">
+          <a:blip>
             <a:extLst>
               <a:ext uri="{28A0092B-C50C-407E-A947-70E740481C1C}">
                 <a14:useLocalDpi xmlns:a14="http://schemas.microsoft.com/office/drawing/2010/main" val="0"/>
               </a:ext>
               <a:ext uri="{96DAC541-7B7A-43D3-8B79-37D633B846F1}">
-                <asvg:svgBlip xmlns:asvg="http://schemas.microsoft.com/office/drawing/2016/SVG/main" r:embed="rId4"/>
+                <asvg:svgBlip xmlns:asvg="http://schemas.microsoft.com/office/drawing/2016/SVG/main" r:embed="rId3"/>
               </a:ext>
             </a:extLst>
           </a:blip>
@@ -23042,10 +23042,10 @@
       </p:sp>
       <p:pic>
         <p:nvPicPr>
-          <p:cNvPr id="7" name="Content Placeholder 6">
+          <p:cNvPr id="8" name="Content Placeholder 7">
             <a:extLst>
               <a:ext uri="{FF2B5EF4-FFF2-40B4-BE49-F238E27FC236}">
-                <a16:creationId xmlns:a16="http://schemas.microsoft.com/office/drawing/2014/main" id="{D9FE7BC4-7779-9101-8DE9-07537C35D8CA}"/>
+                <a16:creationId xmlns:a16="http://schemas.microsoft.com/office/drawing/2014/main" id="{3131F29C-4797-08A6-2B78-C6930E0AAE85}"/>
               </a:ext>
             </a:extLst>
           </p:cNvPr>
@@ -23062,19 +23062,45 @@
             <a:fillRect/>
           </a:stretch>
         </p:blipFill>
-        <p:spPr>
+        <p:spPr bwMode="auto">
           <a:xfrm>
-            <a:off x="2197376" y="1987153"/>
-            <a:ext cx="5692637" cy="3916073"/>
+            <a:off x="6967022" y="2209800"/>
+            <a:ext cx="4921503" cy="2140060"/>
           </a:xfrm>
+          <a:prstGeom prst="rect">
+            <a:avLst/>
+          </a:prstGeom>
+          <a:noFill/>
+          <a:ln>
+            <a:noFill/>
+          </a:ln>
+          <a:extLst>
+            <a:ext uri="{909E8E84-426E-40DD-AFC4-6F175D3DCCD1}">
+              <a14:hiddenFill xmlns:a14="http://schemas.microsoft.com/office/drawing/2010/main">
+                <a:solidFill>
+                  <a:srgbClr val="FFFFFF"/>
+                </a:solidFill>
+              </a14:hiddenFill>
+            </a:ext>
+            <a:ext uri="{91240B29-F687-4F45-9708-019B960494DF}">
+              <a14:hiddenLine xmlns:a14="http://schemas.microsoft.com/office/drawing/2010/main" w="9525">
+                <a:solidFill>
+                  <a:srgbClr val="000000"/>
+                </a:solidFill>
+                <a:miter lim="800000"/>
+                <a:headEnd/>
+                <a:tailEnd/>
+              </a14:hiddenLine>
+            </a:ext>
+          </a:extLst>
         </p:spPr>
       </p:pic>
       <p:pic>
         <p:nvPicPr>
-          <p:cNvPr id="11" name="Picture 10">
+          <p:cNvPr id="5" name="Picture 4">
             <a:extLst>
               <a:ext uri="{FF2B5EF4-FFF2-40B4-BE49-F238E27FC236}">
-                <a16:creationId xmlns:a16="http://schemas.microsoft.com/office/drawing/2014/main" id="{52F422A0-4294-3F7A-372B-0529CBF48FE1}"/>
+                <a16:creationId xmlns:a16="http://schemas.microsoft.com/office/drawing/2014/main" id="{F50D7CCF-3964-C940-EF2D-B4B01EFD39A6}"/>
               </a:ext>
             </a:extLst>
           </p:cNvPr>
@@ -23091,8 +23117,8 @@
         </p:blipFill>
         <p:spPr>
           <a:xfrm>
-            <a:off x="4767543" y="1294391"/>
-            <a:ext cx="5012489" cy="1297418"/>
+            <a:off x="303475" y="1524000"/>
+            <a:ext cx="6400800" cy="4844299"/>
           </a:xfrm>
           <a:prstGeom prst="rect">
             <a:avLst/>

</xml_diff>